<commit_message>
Probar el cliente movil en tablet real y completar sus capturas
- MenuPage: icono y nombre de cada boton en una sola linea (Android solo mostraba el icono).
- MovimientosPage y OperacionPage: ocultar el teclado al consultar o registrar.
- Capturas del movil en una tablet Samsung SM-P610 (login, menu, movimientos y retiro).
- Manual y presentacion regenerados con esas capturas.
</commit_message>
<xml_diff>
--- a/05. DOCUMENTACIÓN/MANUAL_EUREKABANK_SOAP_DOTNET_BDD_GR01.pptx
+++ b/05. DOCUMENTACIÓN/MANUAL_EUREKABANK_SOAP_DOTNET_BDD_GR01.pptx
@@ -122,12 +122,12 @@
   <p:extLst>
     <p:ext uri="{521415D9-36F7-43E2-AB2F-B90AF26B5E84}">
       <p14:sectionLst xmlns:p14="http://schemas.microsoft.com/office/powerpoint/2010/main">
-        <p14:section name="Inicio" id="{d0e006fa-d940-1e36-f220-35bf1f8b5dd1}">
+        <p14:section name="Inicio" id="{6eb8bc87-6d71-a5ed-1520-1fb0a2a41887}">
           <p14:sldIdLst>
             <p14:sldId id="256"/>
           </p14:sldIdLst>
         </p14:section>
-        <p14:section name="Solución" id="{06bfe121-41b3-d85a-1e8e-24c4590af65d}">
+        <p14:section name="Solución" id="{2047ba1b-19c8-0b74-cf4e-a7cf7a3a560e}">
           <p14:sldIdLst>
             <p14:sldId id="257"/>
             <p14:sldId id="258"/>
@@ -135,14 +135,14 @@
             <p14:sldId id="260"/>
           </p14:sldIdLst>
         </p14:section>
-        <p14:section name="Datos" id="{a9c7aa5b-99d3-d8ff-1096-63f50ff25309}">
+        <p14:section name="Datos" id="{fdd47bf8-5330-b792-14a0-46bc698c198e}">
           <p14:sldIdLst>
             <p14:sldId id="261"/>
             <p14:sldId id="262"/>
             <p14:sldId id="263"/>
           </p14:sldIdLst>
         </p14:section>
-        <p14:section name="Clientes" id="{377321b5-4cda-9847-7863-07f5dff9e81f}">
+        <p14:section name="Clientes" id="{b1fd5b80-a186-3422-ded6-2c0e06644d94}">
           <p14:sldIdLst>
             <p14:sldId id="264"/>
             <p14:sldId id="265"/>
@@ -151,13 +151,13 @@
             <p14:sldId id="268"/>
           </p14:sldIdLst>
         </p14:section>
-        <p14:section name="Calidad" id="{9c2b77c6-abaa-fb77-6269-a929fdad2c00}">
+        <p14:section name="Calidad" id="{b0994916-cb24-1542-7685-e86682fd47b1}">
           <p14:sldIdLst>
             <p14:sldId id="269"/>
             <p14:sldId id="270"/>
           </p14:sldIdLst>
         </p14:section>
-        <p14:section name="Cierre" id="{2e91a97d-2a54-625b-d76d-541774c5ec4c}">
+        <p14:section name="Cierre" id="{f4c11570-5dbf-5fe4-e80c-000b24d2175e}">
           <p14:sldIdLst>
             <p14:sldId id="271"/>
           </p14:sldIdLst>
@@ -3909,7 +3909,7 @@
                 <a:ea typeface="Calibri" pitchFamily="34" charset="-122"/>
                 <a:cs typeface="Calibri" pitchFamily="34" charset="-120"/>
               </a:rPr>
-              <a:t>Celular real por WiFi o cable (adb reverse)</a:t>
+              <a:t>Probado en una tablet Samsung SM-P610 (cable con adb reverse)</a:t>
             </a:r>
             <a:endParaRPr lang="en-US" sz="1500" dirty="0"/>
           </a:p>
@@ -3917,18 +3917,74 @@
       </p:sp>
       <p:sp>
         <p:nvSpPr>
-          <p:cNvPr id="6" name="Caja código móvil"/>
+          <p:cNvPr id="6" name="Marco Móvil en la tablet"/>
           <p:cNvSpPr/>
           <p:nvPr/>
         </p:nvSpPr>
         <p:spPr>
           <a:xfrm>
-            <a:off x="4389120" y="1691640"/>
-            <a:ext cx="7269480" cy="1920240"/>
+            <a:off x="5815584" y="1609344"/>
+            <a:ext cx="4416552" cy="2679192"/>
+          </a:xfrm>
+          <a:prstGeom prst="rect">
+            <a:avLst/>
+          </a:prstGeom>
+          <a:solidFill>
+            <a:srgbClr val="FFFFFF"/>
+          </a:solidFill>
+          <a:ln w="12700">
+            <a:solidFill>
+              <a:srgbClr val="DEE2E6"/>
+            </a:solidFill>
+            <a:prstDash val="solid"/>
+          </a:ln>
+          <a:effectLst>
+            <a:outerShdw sx="100000" sy="100000" kx="0" ky="0" algn="bl" rotWithShape="0" blurRad="76200" dist="25400" dir="5400000">
+              <a:srgbClr val="000000">
+                <a:alpha val="18000"/>
+              </a:srgbClr>
+            </a:outerShdw>
+          </a:effectLst>
+        </p:spPr>
+      </p:sp>
+      <p:pic>
+        <p:nvPicPr>
+          <p:cNvPr id="7" name="Móvil en la tablet" descr="Móvil en la tablet">    </p:cNvPr>
+          <p:cNvPicPr>
+            <a:picLocks noChangeAspect="1"/>
+          </p:cNvPicPr>
+          <p:nvPr/>
+        </p:nvPicPr>
+        <p:blipFill>
+          <a:blip r:embed="rId1"/>
+          <a:stretch>
+            <a:fillRect/>
+          </a:stretch>
+        </p:blipFill>
+        <p:spPr>
+          <a:xfrm>
+            <a:off x="5852160" y="1645920"/>
+            <a:ext cx="4343400" cy="2606040"/>
+          </a:xfrm>
+          <a:prstGeom prst="rect">
+            <a:avLst/>
+          </a:prstGeom>
+        </p:spPr>
+      </p:pic>
+      <p:sp>
+        <p:nvSpPr>
+          <p:cNvPr id="8" name="Caja código móvil"/>
+          <p:cNvSpPr/>
+          <p:nvPr/>
+        </p:nvSpPr>
+        <p:spPr>
+          <a:xfrm>
+            <a:off x="4389120" y="4434840"/>
+            <a:ext cx="7269480" cy="1783080"/>
           </a:xfrm>
           <a:prstGeom prst="roundRect">
             <a:avLst>
-              <a:gd name="adj" fmla="val 4762"/>
+              <a:gd name="adj" fmla="val 5128"/>
             </a:avLst>
           </a:prstGeom>
           <a:solidFill>
@@ -3944,14 +4000,14 @@
       </p:sp>
       <p:sp>
         <p:nvSpPr>
-          <p:cNvPr id="7" name="Text 4"/>
+          <p:cNvPr id="9" name="Text 5"/>
           <p:cNvSpPr txBox="1"/>
           <p:nvPr/>
         </p:nvSpPr>
         <p:spPr>
           <a:xfrm>
-            <a:off x="4480560" y="1783080"/>
-            <a:ext cx="7086600" cy="1737360"/>
+            <a:off x="4480560" y="4526280"/>
+            <a:ext cx="7086600" cy="1600200"/>
           </a:xfrm>
           <a:prstGeom prst="rect">
             <a:avLst/>

</xml_diff>

<commit_message>
Clientes solo de presentacion: datos y contrato desde el WSDL, reglas en el servidor
- Consola y escritorio: proxy WSEurekaReference.cs generado con SvcUtil; web y movil con dotnet-svcutil.
  Se eliminan las copias a mano del contrato (IWSEureka) y de los modelos (Empleado, Cuenta, Movimiento).
- Los clientes ya no validan reglas del banco (8 digitos, importe, cuentas distintas): solo campos vacios
  y que el importe sea numero; el resto lo valida el servidor y se muestra su mensaje.
- Movil: ChannelFactory<WSEureka> con System.ServiceModel.Http en lugar del sobre SOAP armado a mano.
- README, LEEME, diagrama de clases de clientes, ERS, manual y presentacion actualizados; manual incluye el ASMX.
</commit_message>
<xml_diff>
--- a/05. DOCUMENTACIÓN/MANUAL_EUREKABANK_SOAP_DOTNET_BDD_GR01.pptx
+++ b/05. DOCUMENTACIÓN/MANUAL_EUREKABANK_SOAP_DOTNET_BDD_GR01.pptx
@@ -122,12 +122,12 @@
   <p:extLst>
     <p:ext uri="{521415D9-36F7-43E2-AB2F-B90AF26B5E84}">
       <p14:sectionLst xmlns:p14="http://schemas.microsoft.com/office/powerpoint/2010/main">
-        <p14:section name="Inicio" id="{6eb8bc87-6d71-a5ed-1520-1fb0a2a41887}">
+        <p14:section name="Inicio" id="{98f8a069-595a-9148-dfae-97182765805c}">
           <p14:sldIdLst>
             <p14:sldId id="256"/>
           </p14:sldIdLst>
         </p14:section>
-        <p14:section name="Solución" id="{2047ba1b-19c8-0b74-cf4e-a7cf7a3a560e}">
+        <p14:section name="Solución" id="{9a41ea74-34b1-8991-27d4-da4419a9d3f5}">
           <p14:sldIdLst>
             <p14:sldId id="257"/>
             <p14:sldId id="258"/>
@@ -135,14 +135,14 @@
             <p14:sldId id="260"/>
           </p14:sldIdLst>
         </p14:section>
-        <p14:section name="Datos" id="{fdd47bf8-5330-b792-14a0-46bc698c198e}">
+        <p14:section name="Datos" id="{309aa941-635b-ead7-ddb0-7363eb386f8f}">
           <p14:sldIdLst>
             <p14:sldId id="261"/>
             <p14:sldId id="262"/>
             <p14:sldId id="263"/>
           </p14:sldIdLst>
         </p14:section>
-        <p14:section name="Clientes" id="{b1fd5b80-a186-3422-ded6-2c0e06644d94}">
+        <p14:section name="Clientes" id="{7b7b5328-a10b-e26c-e746-d17787303cd5}">
           <p14:sldIdLst>
             <p14:sldId id="264"/>
             <p14:sldId id="265"/>
@@ -151,13 +151,13 @@
             <p14:sldId id="268"/>
           </p14:sldIdLst>
         </p14:section>
-        <p14:section name="Calidad" id="{b0994916-cb24-1542-7685-e86682fd47b1}">
+        <p14:section name="Calidad" id="{17c9623b-4ebf-4f3f-c7d0-79169503f968}">
           <p14:sldIdLst>
             <p14:sldId id="269"/>
             <p14:sldId id="270"/>
           </p14:sldIdLst>
         </p14:section>
-        <p14:section name="Cierre" id="{f4c11570-5dbf-5fe4-e80c-000b24d2175e}">
+        <p14:section name="Cierre" id="{bb4d4acf-46d8-a556-466f-f0d5ae4447dc}">
           <p14:sldIdLst>
             <p14:sldId id="271"/>
           </p14:sldIdLst>
@@ -830,7 +830,7 @@
           <a:p>
             <a:r>
               <a:rPr lang="en-US" dirty="0"/>
-              <a:t>System.ServiceModel no existe en Android: se arma el sobre XML.</a:t>
+              <a:t>El móvil usa System.ServiceModel.Http con el proxy generado desde el WSDL.</a:t>
             </a:r>
             <a:endParaRPr lang="en-US" dirty="0"/>
           </a:p>
@@ -3060,7 +3060,7 @@
                 <a:ea typeface="Calibri" pitchFamily="34" charset="-122"/>
                 <a:cs typeface="Calibri" pitchFamily="34" charset="-120"/>
               </a:rPr>
-              <a:t>Windows Forms · .NET Framework 4.7.2 · llamadas asíncronas</a:t>
+              <a:t>Windows Forms · .NET Framework 4.7.2 · proxy generado del WSDL</a:t>
             </a:r>
             <a:endParaRPr lang="en-US" sz="1600" dirty="0"/>
           </a:p>
@@ -3187,7 +3187,7 @@
                 <a:ea typeface="Calibri" pitchFamily="34" charset="-122"/>
                 <a:cs typeface="Calibri" pitchFamily="34" charset="-120"/>
               </a:rPr>
-              <a:t>Operaciones de la sesión a la derecha</a:t>
+              <a:t>Mensajes de error que envía el servidor</a:t>
             </a:r>
             <a:endParaRPr lang="en-US" sz="1500" dirty="0"/>
           </a:p>
@@ -3393,7 +3393,7 @@
                 <a:ea typeface="Calibri" pitchFamily="34" charset="-122"/>
                 <a:cs typeface="Calibri" pitchFamily="34" charset="-120"/>
               </a:rPr>
-              <a:t>ASP.NET Core MVC · .NET 8 · System.ServiceModel</a:t>
+              <a:t>ASP.NET Core MVC · .NET 8 · proxy generado con dotnet-svcutil</a:t>
             </a:r>
             <a:endParaRPr lang="en-US" sz="1600" dirty="0"/>
           </a:p>
@@ -3782,7 +3782,7 @@
                 <a:ea typeface="Calibri" pitchFamily="34" charset="-122"/>
                 <a:cs typeface="Calibri" pitchFamily="34" charset="-120"/>
               </a:rPr>
-              <a:t>.NET MAUI (sucesor de Xamarin) · C# · Android · SOAP con HttpClient</a:t>
+              <a:t>.NET MAUI (sucesor de Xamarin) · C# · Android · proxy WCF del WSDL</a:t>
             </a:r>
             <a:endParaRPr lang="en-US" sz="1600" dirty="0"/>
           </a:p>
@@ -3846,7 +3846,7 @@
                 <a:ea typeface="Calibri" pitchFamily="34" charset="-122"/>
                 <a:cs typeface="Calibri" pitchFamily="34" charset="-120"/>
               </a:rPr>
-              <a:t>Sobre SOAP armado a mano y leído con LINQ to XML</a:t>
+              <a:t>Mismo proxy de la web (dotnet-svcutil)</a:t>
             </a:r>
             <a:endParaRPr lang="en-US" sz="1500" dirty="0"/>
           </a:p>
@@ -4031,7 +4031,7 @@
                 <a:ea typeface="Consolas" pitchFamily="34" charset="-122"/>
                 <a:cs typeface="Consolas" pitchFamily="34" charset="-120"/>
               </a:rPr>
-              <a:t>var peticion = new HttpRequestMessage(HttpMethod.Post, url) {</a:t>
+              <a:t>// WSEurekaReference.cs: generado desde el WSDL con dotnet-svcutil</a:t>
             </a:r>
             <a:endParaRPr lang="en-US" sz="1200" dirty="0"/>
           </a:p>
@@ -4048,7 +4048,7 @@
                 <a:ea typeface="Consolas" pitchFamily="34" charset="-122"/>
                 <a:cs typeface="Consolas" pitchFamily="34" charset="-120"/>
               </a:rPr>
-              <a:t>  Content = new StringContent(sobre, Encoding.UTF8, "text/xml") };</a:t>
+              <a:t>_fabrica = new ChannelFactory&lt;WSEureka&gt;(binding, new EndpointAddress(url));</a:t>
             </a:r>
             <a:endParaRPr lang="en-US" sz="1200" dirty="0"/>
           </a:p>
@@ -4065,7 +4065,7 @@
                 <a:ea typeface="Consolas" pitchFamily="34" charset="-122"/>
                 <a:cs typeface="Consolas" pitchFamily="34" charset="-120"/>
               </a:rPr>
-              <a:t>peticion.Headers.Add("SOAPAction",</a:t>
+              <a:t>WSEureka canal = _fabrica.CreateChannel();</a:t>
             </a:r>
             <a:endParaRPr lang="en-US" sz="1200" dirty="0"/>
           </a:p>
@@ -4082,7 +4082,7 @@
                 <a:ea typeface="Consolas" pitchFamily="34" charset="-122"/>
                 <a:cs typeface="Consolas" pitchFamily="34" charset="-120"/>
               </a:rPr>
-              <a:t>  "\"http://espe.edu.ec/eureka/WSEureka/" + operacion + "\"");</a:t>
+              <a:t>Empleado? e = await canal.loginAsync(usuario, clave);</a:t>
             </a:r>
             <a:endParaRPr lang="en-US" sz="1200" dirty="0"/>
           </a:p>
@@ -4099,7 +4099,7 @@
                 <a:ea typeface="Consolas" pitchFamily="34" charset="-122"/>
                 <a:cs typeface="Consolas" pitchFamily="34" charset="-120"/>
               </a:rPr>
-              <a:t>XElement r = Buscar(operacion + "Result");   // o el &lt;Mensaje&gt; del Fault</a:t>
+              <a:t>// Fault -&gt; FaultException&lt;ErrorServicio&gt; -&gt; mensaje del servidor</a:t>
             </a:r>
             <a:endParaRPr lang="en-US" sz="1200" dirty="0"/>
           </a:p>
@@ -14280,7 +14280,7 @@
                 <a:ea typeface="Calibri" pitchFamily="34" charset="-122"/>
                 <a:cs typeface="Calibri" pitchFamily="34" charset="-120"/>
               </a:rPr>
-              <a:t>.NET Framework 4.7.2 · ChannelFactory&lt;IWSEureka&gt; · MVC</a:t>
+              <a:t>.NET Framework 4.7.2 · proxy generado del WSDL (SvcUtil) · MVC</a:t>
             </a:r>
             <a:endParaRPr lang="en-US" sz="1600" dirty="0"/>
           </a:p>
@@ -14407,7 +14407,7 @@
                 <a:ea typeface="Calibri" pitchFamily="34" charset="-122"/>
                 <a:cs typeface="Calibri" pitchFamily="34" charset="-120"/>
               </a:rPr>
-              <a:t>URL del servidor en App.config</a:t>
+              <a:t>Sin reglas del banco: las valida el servidor</a:t>
             </a:r>
             <a:endParaRPr lang="en-US" sz="1500" dirty="0"/>
           </a:p>

</xml_diff>

<commit_message>
Clientes como el GR05: modelos get/set, controlador que solo pasa llamadas, intentos de login en el servidor, clave monster69 e imagen monster
</commit_message>
<xml_diff>
--- a/05. DOCUMENTACIÓN/MANUAL_EUREKABANK_SOAP_DOTNET_BDD_GR01.pptx
+++ b/05. DOCUMENTACIÓN/MANUAL_EUREKABANK_SOAP_DOTNET_BDD_GR01.pptx
@@ -122,12 +122,12 @@
   <p:extLst>
     <p:ext uri="{521415D9-36F7-43E2-AB2F-B90AF26B5E84}">
       <p14:sectionLst xmlns:p14="http://schemas.microsoft.com/office/powerpoint/2010/main">
-        <p14:section name="Inicio" id="{98f8a069-595a-9148-dfae-97182765805c}">
+        <p14:section name="Inicio" id="{46b37399-53d1-171f-0440-165350c92816}">
           <p14:sldIdLst>
             <p14:sldId id="256"/>
           </p14:sldIdLst>
         </p14:section>
-        <p14:section name="Solución" id="{9a41ea74-34b1-8991-27d4-da4419a9d3f5}">
+        <p14:section name="Solución" id="{9744775d-ae1f-691c-89f5-98c18ac5e967}">
           <p14:sldIdLst>
             <p14:sldId id="257"/>
             <p14:sldId id="258"/>
@@ -135,14 +135,14 @@
             <p14:sldId id="260"/>
           </p14:sldIdLst>
         </p14:section>
-        <p14:section name="Datos" id="{309aa941-635b-ead7-ddb0-7363eb386f8f}">
+        <p14:section name="Datos" id="{7d495d4a-aa1d-d8ec-2b21-6f6616a951fe}">
           <p14:sldIdLst>
             <p14:sldId id="261"/>
             <p14:sldId id="262"/>
             <p14:sldId id="263"/>
           </p14:sldIdLst>
         </p14:section>
-        <p14:section name="Clientes" id="{7b7b5328-a10b-e26c-e746-d17787303cd5}">
+        <p14:section name="Clientes" id="{6d3bac6a-bbdd-a385-01db-3144484bcea6}">
           <p14:sldIdLst>
             <p14:sldId id="264"/>
             <p14:sldId id="265"/>
@@ -151,13 +151,13 @@
             <p14:sldId id="268"/>
           </p14:sldIdLst>
         </p14:section>
-        <p14:section name="Calidad" id="{17c9623b-4ebf-4f3f-c7d0-79169503f968}">
+        <p14:section name="Calidad" id="{9bef23e0-f100-0a1d-6066-a0ca8ae33f51}">
           <p14:sldIdLst>
             <p14:sldId id="269"/>
             <p14:sldId id="270"/>
           </p14:sldIdLst>
         </p14:section>
-        <p14:section name="Cierre" id="{bb4d4acf-46d8-a556-466f-f0d5ae4447dc}">
+        <p14:section name="Cierre" id="{9213e998-fe38-9d64-614c-588340b005db}">
           <p14:sldIdLst>
             <p14:sldId id="271"/>
           </p14:sldIdLst>
@@ -830,7 +830,7 @@
           <a:p>
             <a:r>
               <a:rPr lang="en-US" dirty="0"/>
-              <a:t>El móvil usa System.ServiceModel.Http con el proxy generado desde el WSDL.</a:t>
+              <a:t>El móvil arma el sobre SOAP con HttpClient y muestra el mensaje del Fault.</a:t>
             </a:r>
             <a:endParaRPr lang="en-US" dirty="0"/>
           </a:p>
@@ -3060,7 +3060,7 @@
                 <a:ea typeface="Calibri" pitchFamily="34" charset="-122"/>
                 <a:cs typeface="Calibri" pitchFamily="34" charset="-120"/>
               </a:rPr>
-              <a:t>Windows Forms · .NET Framework 4.7.2 · proxy generado del WSDL</a:t>
+              <a:t>Windows Forms · .NET Framework 4.7.2 · modelos get/set</a:t>
             </a:r>
             <a:endParaRPr lang="en-US" sz="1600" dirty="0"/>
           </a:p>
@@ -3393,7 +3393,7 @@
                 <a:ea typeface="Calibri" pitchFamily="34" charset="-122"/>
                 <a:cs typeface="Calibri" pitchFamily="34" charset="-120"/>
               </a:rPr>
-              <a:t>ASP.NET Core MVC · .NET 8 · proxy generado con dotnet-svcutil</a:t>
+              <a:t>ASP.NET Core MVC · .NET 8 · System.ServiceModel.Http</a:t>
             </a:r>
             <a:endParaRPr lang="en-US" sz="1600" dirty="0"/>
           </a:p>
@@ -3782,7 +3782,7 @@
                 <a:ea typeface="Calibri" pitchFamily="34" charset="-122"/>
                 <a:cs typeface="Calibri" pitchFamily="34" charset="-120"/>
               </a:rPr>
-              <a:t>.NET MAUI (sucesor de Xamarin) · C# · Android · proxy WCF del WSDL</a:t>
+              <a:t>.NET MAUI (sucesor de Xamarin) · C# · Android · SOAP con HttpClient</a:t>
             </a:r>
             <a:endParaRPr lang="en-US" sz="1600" dirty="0"/>
           </a:p>
@@ -3846,7 +3846,7 @@
                 <a:ea typeface="Calibri" pitchFamily="34" charset="-122"/>
                 <a:cs typeface="Calibri" pitchFamily="34" charset="-120"/>
               </a:rPr>
-              <a:t>Mismo proxy de la web (dotnet-svcutil)</a:t>
+              <a:t>Modelos get/set llenados desde el XML</a:t>
             </a:r>
             <a:endParaRPr lang="en-US" sz="1500" dirty="0"/>
           </a:p>
@@ -4031,7 +4031,7 @@
                 <a:ea typeface="Consolas" pitchFamily="34" charset="-122"/>
                 <a:cs typeface="Consolas" pitchFamily="34" charset="-120"/>
               </a:rPr>
-              <a:t>// WSEurekaReference.cs: generado desde el WSDL con dotnet-svcutil</a:t>
+              <a:t>XElement r = await InvocarAsync("login", ("usuario", u), ("clave", c));</a:t>
             </a:r>
             <a:endParaRPr lang="en-US" sz="1200" dirty="0"/>
           </a:p>
@@ -4048,7 +4048,7 @@
                 <a:ea typeface="Consolas" pitchFamily="34" charset="-122"/>
                 <a:cs typeface="Consolas" pitchFamily="34" charset="-120"/>
               </a:rPr>
-              <a:t>_fabrica = new ChannelFactory&lt;WSEureka&gt;(binding, new EndpointAddress(url));</a:t>
+              <a:t>return new Empleado {</a:t>
             </a:r>
             <a:endParaRPr lang="en-US" sz="1200" dirty="0"/>
           </a:p>
@@ -4065,7 +4065,7 @@
                 <a:ea typeface="Consolas" pitchFamily="34" charset="-122"/>
                 <a:cs typeface="Consolas" pitchFamily="34" charset="-120"/>
               </a:rPr>
-              <a:t>WSEureka canal = _fabrica.CreateChannel();</a:t>
+              <a:t>  Codigo = Texto(r, "Codigo"), Usuario = Texto(r, "Usuario"),</a:t>
             </a:r>
             <a:endParaRPr lang="en-US" sz="1200" dirty="0"/>
           </a:p>
@@ -4082,7 +4082,7 @@
                 <a:ea typeface="Consolas" pitchFamily="34" charset="-122"/>
                 <a:cs typeface="Consolas" pitchFamily="34" charset="-120"/>
               </a:rPr>
-              <a:t>Empleado? e = await canal.loginAsync(usuario, clave);</a:t>
+              <a:t>  Nombre = Texto(r, "Nombre") };</a:t>
             </a:r>
             <a:endParaRPr lang="en-US" sz="1200" dirty="0"/>
           </a:p>
@@ -4099,7 +4099,7 @@
                 <a:ea typeface="Consolas" pitchFamily="34" charset="-122"/>
                 <a:cs typeface="Consolas" pitchFamily="34" charset="-120"/>
               </a:rPr>
-              <a:t>// Fault -&gt; FaultException&lt;ErrorServicio&gt; -&gt; mensaje del servidor</a:t>
+              <a:t>// Fault -&gt; ErrorServicioException(&lt;Mensaje&gt; del servidor)</a:t>
             </a:r>
             <a:endParaRPr lang="en-US" sz="1200" dirty="0"/>
           </a:p>
@@ -5837,7 +5837,7 @@
                             <a:srgbClr val="212529"/>
                           </a:solidFill>
                         </a:rPr>
-                        <a:t>monster / monster</a:t>
+                        <a:t>monster / monster69</a:t>
                       </a:r>
                       <a:endParaRPr lang="en-US" sz="1300" dirty="0"/>
                     </a:p>
@@ -9679,7 +9679,7 @@
                             <a:srgbClr val="212529"/>
                           </a:solidFill>
                         </a:rPr>
-                        <a:t>Empleado o nil</a:t>
+                        <a:t>Empleado o Fault</a:t>
                       </a:r>
                       <a:endParaRPr lang="en-US" sz="1500" dirty="0"/>
                     </a:p>
@@ -14280,7 +14280,7 @@
                 <a:ea typeface="Calibri" pitchFamily="34" charset="-122"/>
                 <a:cs typeface="Calibri" pitchFamily="34" charset="-120"/>
               </a:rPr>
-              <a:t>.NET Framework 4.7.2 · proxy generado del WSDL (SvcUtil) · MVC</a:t>
+              <a:t>.NET Framework 4.7.2 · ChannelFactory&lt;IWSEureka&gt; · MVC</a:t>
             </a:r>
             <a:endParaRPr lang="en-US" sz="1600" dirty="0"/>
           </a:p>
@@ -14323,7 +14323,7 @@
                 <a:ea typeface="Calibri" pitchFamily="34" charset="-122"/>
                 <a:cs typeface="Calibri" pitchFamily="34" charset="-120"/>
               </a:rPr>
-              <a:t>Login con clave oculta y 3 intentos</a:t>
+              <a:t>Login con clave oculta (los 3 intentos los cuenta el servidor)</a:t>
             </a:r>
             <a:endParaRPr lang="en-US" sz="1500" dirty="0"/>
           </a:p>

</xml_diff>

<commit_message>
Nuevas capturas (consola, escritorio, web y servidor en IIS) con monster69 e imagen; manual y presentacion regenerados
</commit_message>
<xml_diff>
--- a/05. DOCUMENTACIÓN/MANUAL_EUREKABANK_SOAP_DOTNET_BDD_GR01.pptx
+++ b/05. DOCUMENTACIÓN/MANUAL_EUREKABANK_SOAP_DOTNET_BDD_GR01.pptx
@@ -122,12 +122,12 @@
   <p:extLst>
     <p:ext uri="{521415D9-36F7-43E2-AB2F-B90AF26B5E84}">
       <p14:sectionLst xmlns:p14="http://schemas.microsoft.com/office/powerpoint/2010/main">
-        <p14:section name="Inicio" id="{46b37399-53d1-171f-0440-165350c92816}">
+        <p14:section name="Inicio" id="{70f3494c-24ad-6784-c4d7-1cd4de177a69}">
           <p14:sldIdLst>
             <p14:sldId id="256"/>
           </p14:sldIdLst>
         </p14:section>
-        <p14:section name="Solución" id="{9744775d-ae1f-691c-89f5-98c18ac5e967}">
+        <p14:section name="Solución" id="{c164dcbc-3767-d268-8e01-61a522e5c70c}">
           <p14:sldIdLst>
             <p14:sldId id="257"/>
             <p14:sldId id="258"/>
@@ -135,14 +135,14 @@
             <p14:sldId id="260"/>
           </p14:sldIdLst>
         </p14:section>
-        <p14:section name="Datos" id="{7d495d4a-aa1d-d8ec-2b21-6f6616a951fe}">
+        <p14:section name="Datos" id="{8951eba5-828b-bcf4-4b55-a8ef365beb68}">
           <p14:sldIdLst>
             <p14:sldId id="261"/>
             <p14:sldId id="262"/>
             <p14:sldId id="263"/>
           </p14:sldIdLst>
         </p14:section>
-        <p14:section name="Clientes" id="{6d3bac6a-bbdd-a385-01db-3144484bcea6}">
+        <p14:section name="Clientes" id="{74f75c01-6f62-ab63-3c01-454d9a296a43}">
           <p14:sldIdLst>
             <p14:sldId id="264"/>
             <p14:sldId id="265"/>
@@ -151,13 +151,13 @@
             <p14:sldId id="268"/>
           </p14:sldIdLst>
         </p14:section>
-        <p14:section name="Calidad" id="{9bef23e0-f100-0a1d-6066-a0ca8ae33f51}">
+        <p14:section name="Calidad" id="{4253c4ed-f61c-2cbe-2094-7c35ab2931f5}">
           <p14:sldIdLst>
             <p14:sldId id="269"/>
             <p14:sldId id="270"/>
           </p14:sldIdLst>
         </p14:section>
-        <p14:section name="Cierre" id="{9213e998-fe38-9d64-614c-588340b005db}">
+        <p14:section name="Cierre" id="{a7139b5c-7445-40d3-8774-7bf91e3d2a7f}">
           <p14:sldIdLst>
             <p14:sldId id="271"/>
           </p14:sldIdLst>

</xml_diff>